<commit_message>
Add proposal PPTX: Miiko Anderson Law (October 21, 2026)
Rebuilt for Coach Essentials Plus + complimentary LSA Management Add-On.

Co-Authored-By: Claude <noreply@anthropic.com>
</commit_message>
<xml_diff>
--- a/miiko-anderson/MiikoAndersonLaw_October212026_Proposal.pptx
+++ b/miiko-anderson/MiikoAndersonLaw_October212026_Proposal.pptx
@@ -3460,7 +3460,7 @@
                 </a:solidFill>
                 <a:latin typeface="Poppins"/>
               </a:rPr>
-              <a:t>“I think the biggest challenge that I'm facing right now partly is branding.”</a:t>
+              <a:t>“That space in between the beats kind of does make me nervous”</a:t>
             </a:r>
           </a:p>
         </p:txBody>
@@ -4999,7 +4999,7 @@
                 </a:solidFill>
                 <a:latin typeface="Poppins"/>
               </a:rPr>
-              <a:t>Build Your Client</a:t>
+              <a:t>Open a Second</a:t>
             </a:r>
           </a:p>
         </p:txBody>
@@ -5034,7 +5034,7 @@
                 </a:solidFill>
                 <a:latin typeface="Poppins"/>
               </a:rPr>
-              <a:t>Pipeline</a:t>
+              <a:t>Client Source</a:t>
             </a:r>
           </a:p>
         </p:txBody>
@@ -5120,7 +5120,7 @@
                 </a:solidFill>
                 <a:latin typeface="Poppins"/>
               </a:rPr>
-              <a:t>Optimize Google Business Profile, build steady reviews</a:t>
+              <a:t>Launch Local Service Ads for Fresno criminal defense</a:t>
             </a:r>
           </a:p>
           <a:p>
@@ -5141,7 +5141,7 @@
                 </a:solidFill>
                 <a:latin typeface="Poppins"/>
               </a:rPr>
-              <a:t>Turn your website into a lead source, not a referral check</a:t>
+              <a:t>Pay only when a real prospect calls you</a:t>
             </a:r>
           </a:p>
           <a:p>
@@ -5162,7 +5162,7 @@
                 </a:solidFill>
                 <a:latin typeface="Poppins"/>
               </a:rPr>
-              <a:t>Run managed ads so new clients find you in Fresno</a:t>
+              <a:t>Review leads and cost per lead together each month</a:t>
             </a:r>
           </a:p>
           <a:p>
@@ -5183,7 +5183,7 @@
                 </a:solidFill>
                 <a:latin typeface="Poppins"/>
               </a:rPr>
-              <a:t>Make the law firm the first result for your own name</a:t>
+              <a:t>Quiet stretches stop dictating your week</a:t>
             </a:r>
           </a:p>
           <a:p>
@@ -5204,7 +5204,7 @@
                 </a:solidFill>
                 <a:latin typeface="Poppins"/>
               </a:rPr>
-              <a:t>A second source, so quiet months stop worrying you</a:t>
+              <a:t>Later: add a website and local search foundation</a:t>
             </a:r>
           </a:p>
         </p:txBody>
@@ -5319,7 +5319,7 @@
                 </a:solidFill>
                 <a:latin typeface="Poppins"/>
               </a:rPr>
-              <a:t>Fix Intake &amp;</a:t>
+              <a:t>Coach the Firm</a:t>
             </a:r>
           </a:p>
         </p:txBody>
@@ -5354,7 +5354,7 @@
                 </a:solidFill>
                 <a:latin typeface="Poppins"/>
               </a:rPr>
-              <a:t>Follow-Up</a:t>
+              <a:t>You Want to Build</a:t>
             </a:r>
           </a:p>
         </p:txBody>
@@ -5440,7 +5440,7 @@
                 </a:solidFill>
                 <a:latin typeface="Poppins"/>
               </a:rPr>
-              <a:t>Add one clear way to request a consult on the homepage</a:t>
+              <a:t>Group coaching alongside other law firm owners</a:t>
             </a:r>
           </a:p>
           <a:p>
@@ -5461,7 +5461,7 @@
                 </a:solidFill>
                 <a:latin typeface="Poppins"/>
               </a:rPr>
-              <a:t>Follow up on every consult that does not sign right away</a:t>
+              <a:t>Monthly 1:1 call to work through your options</a:t>
             </a:r>
           </a:p>
           <a:p>
@@ -5482,7 +5482,7 @@
                 </a:solidFill>
                 <a:latin typeface="Poppins"/>
               </a:rPr>
-              <a:t>Use the Clio you already have to keep follow-up steady</a:t>
+              <a:t>Map the order of your first associate hire</a:t>
             </a:r>
           </a:p>
           <a:p>
@@ -5503,7 +5503,7 @@
                 </a:solidFill>
                 <a:latin typeface="Poppins"/>
               </a:rPr>
-              <a:t>Be ready for faster-moving leads from search and ads</a:t>
+              <a:t>Write down intake and case steps for new hires</a:t>
             </a:r>
           </a:p>
           <a:p>
@@ -5524,7 +5524,7 @@
                 </a:solidFill>
                 <a:latin typeface="Poppins"/>
               </a:rPr>
-              <a:t>Take the first call off your plate over time</a:t>
+              <a:t>Build a firm that does not need you in every case</a:t>
             </a:r>
           </a:p>
         </p:txBody>
@@ -5639,7 +5639,7 @@
                 </a:solidFill>
                 <a:latin typeface="Poppins"/>
               </a:rPr>
-              <a:t>Install Team &amp;</a:t>
+              <a:t>Steady Follow-Up &amp;</a:t>
             </a:r>
           </a:p>
         </p:txBody>
@@ -5674,7 +5674,7 @@
                 </a:solidFill>
                 <a:latin typeface="Poppins"/>
               </a:rPr>
-              <a:t>Profit Systems</a:t>
+              <a:t>Clear Numbers</a:t>
             </a:r>
           </a:p>
         </p:txBody>
@@ -5760,7 +5760,7 @@
                 </a:solidFill>
                 <a:latin typeface="Poppins"/>
               </a:rPr>
-              <a:t>Write down intake and case steps for your first hire</a:t>
+              <a:t>Add one clear way to request a consult on the homepage</a:t>
             </a:r>
           </a:p>
           <a:p>
@@ -5781,7 +5781,7 @@
                 </a:solidFill>
                 <a:latin typeface="Poppins"/>
               </a:rPr>
-              <a:t>Set the revenue target that funds two associates</a:t>
+              <a:t>Follow up on consults that do not sign right away</a:t>
             </a:r>
           </a:p>
           <a:p>
@@ -5802,7 +5802,7 @@
                 </a:solidFill>
                 <a:latin typeface="Poppins"/>
               </a:rPr>
-              <a:t>Put bookkeeping in place for clear monthly numbers</a:t>
+              <a:t>Use the Clio you already have to keep follow-up steady</a:t>
             </a:r>
           </a:p>
           <a:p>
@@ -5823,7 +5823,7 @@
                 </a:solidFill>
                 <a:latin typeface="Poppins"/>
               </a:rPr>
-              <a:t>Hire once lead flow is steady, not before</a:t>
+              <a:t>Set the revenue target that funds two associates</a:t>
             </a:r>
           </a:p>
           <a:p>
@@ -5844,7 +5844,7 @@
                 </a:solidFill>
                 <a:latin typeface="Poppins"/>
               </a:rPr>
-              <a:t>Build a firm that does not need you in every case</a:t>
+              <a:t>Track monthly numbers so hiring is a plan, not a guess</a:t>
             </a:r>
           </a:p>
         </p:txBody>
@@ -6226,6 +6226,271 @@
             <a:avLst/>
           </a:prstGeom>
           <a:solidFill>
+            <a:srgbClr val="003A59"/>
+          </a:solidFill>
+          <a:ln>
+            <a:solidFill>
+              <a:srgbClr val="FFFFFF"/>
+            </a:solidFill>
+          </a:ln>
+        </p:spPr>
+        <p:style>
+          <a:lnRef idx="1">
+            <a:schemeClr val="accent1"/>
+          </a:lnRef>
+          <a:fillRef idx="3">
+            <a:schemeClr val="accent1"/>
+          </a:fillRef>
+          <a:effectRef idx="2">
+            <a:schemeClr val="accent1"/>
+          </a:effectRef>
+          <a:fontRef idx="minor">
+            <a:schemeClr val="lt1"/>
+          </a:fontRef>
+        </p:style>
+        <p:txBody>
+          <a:bodyPr rtlCol="0" anchor="ctr"/>
+          <a:lstStyle/>
+          <a:p>
+            <a:pPr algn="ctr"/>
+          </a:p>
+        </p:txBody>
+      </p:sp>
+      <p:sp>
+        <p:nvSpPr>
+          <p:cNvPr id="8" name="TextBox 7"/>
+          <p:cNvSpPr txBox="1"/>
+          <p:nvPr/>
+        </p:nvSpPr>
+        <p:spPr>
+          <a:xfrm>
+            <a:off x="512064" y="1115568"/>
+            <a:ext cx="3621024" cy="182880"/>
+          </a:xfrm>
+          <a:prstGeom prst="rect">
+            <a:avLst/>
+          </a:prstGeom>
+          <a:noFill/>
+        </p:spPr>
+        <p:txBody>
+          <a:bodyPr wrap="square">
+            <a:noAutofit/>
+          </a:bodyPr>
+          <a:lstStyle/>
+          <a:p>
+            <a:pPr algn="l"/>
+            <a:r>
+              <a:rPr sz="750" b="1" i="0">
+                <a:solidFill>
+                  <a:srgbClr val="003A59"/>
+                </a:solidFill>
+                <a:latin typeface="Poppins"/>
+              </a:rPr>
+              <a:t>COACH ESSENTIALS PLUS</a:t>
+            </a:r>
+          </a:p>
+        </p:txBody>
+      </p:sp>
+      <p:sp>
+        <p:nvSpPr>
+          <p:cNvPr id="9" name="TextBox 8"/>
+          <p:cNvSpPr txBox="1"/>
+          <p:nvPr/>
+        </p:nvSpPr>
+        <p:spPr>
+          <a:xfrm>
+            <a:off x="512064" y="1252728"/>
+            <a:ext cx="2377440" cy="530352"/>
+          </a:xfrm>
+          <a:prstGeom prst="rect">
+            <a:avLst/>
+          </a:prstGeom>
+          <a:noFill/>
+        </p:spPr>
+        <p:txBody>
+          <a:bodyPr wrap="square">
+            <a:noAutofit/>
+          </a:bodyPr>
+          <a:lstStyle/>
+          <a:p>
+            <a:pPr algn="l"/>
+            <a:r>
+              <a:rPr sz="3000" b="1" i="0">
+                <a:solidFill>
+                  <a:srgbClr val="003A59"/>
+                </a:solidFill>
+                <a:latin typeface="Poppins"/>
+              </a:rPr>
+              <a:t>$2,497</a:t>
+            </a:r>
+          </a:p>
+        </p:txBody>
+      </p:sp>
+      <p:sp>
+        <p:nvSpPr>
+          <p:cNvPr id="10" name="TextBox 9"/>
+          <p:cNvSpPr txBox="1"/>
+          <p:nvPr/>
+        </p:nvSpPr>
+        <p:spPr>
+          <a:xfrm>
+            <a:off x="1822323" y="1519428"/>
+            <a:ext cx="457200" cy="219456"/>
+          </a:xfrm>
+          <a:prstGeom prst="rect">
+            <a:avLst/>
+          </a:prstGeom>
+          <a:noFill/>
+        </p:spPr>
+        <p:txBody>
+          <a:bodyPr wrap="none">
+            <a:noAutofit/>
+          </a:bodyPr>
+          <a:lstStyle/>
+          <a:p>
+            <a:pPr algn="l"/>
+            <a:r>
+              <a:rPr sz="1000" b="0" i="0">
+                <a:solidFill>
+                  <a:srgbClr val="7C8D9B"/>
+                </a:solidFill>
+                <a:latin typeface="Poppins"/>
+              </a:rPr>
+              <a:t>/mo</a:t>
+            </a:r>
+          </a:p>
+        </p:txBody>
+      </p:sp>
+      <p:sp>
+        <p:nvSpPr>
+          <p:cNvPr id="11" name="TextBox 10"/>
+          <p:cNvSpPr txBox="1"/>
+          <p:nvPr/>
+        </p:nvSpPr>
+        <p:spPr>
+          <a:xfrm>
+            <a:off x="2332609" y="1519428"/>
+            <a:ext cx="1891918" cy="219456"/>
+          </a:xfrm>
+          <a:prstGeom prst="rect">
+            <a:avLst/>
+          </a:prstGeom>
+          <a:noFill/>
+        </p:spPr>
+        <p:txBody>
+          <a:bodyPr wrap="square">
+            <a:noAutofit/>
+          </a:bodyPr>
+          <a:lstStyle/>
+          <a:p>
+            <a:pPr algn="r"/>
+            <a:r>
+              <a:rPr sz="1000" b="0" i="0">
+                <a:solidFill>
+                  <a:srgbClr val="7C8D9B"/>
+                </a:solidFill>
+                <a:latin typeface="Poppins"/>
+              </a:rPr>
+              <a:t>stand-alone price</a:t>
+            </a:r>
+          </a:p>
+        </p:txBody>
+      </p:sp>
+      <p:sp>
+        <p:nvSpPr>
+          <p:cNvPr id="12" name="TextBox 11"/>
+          <p:cNvSpPr txBox="1"/>
+          <p:nvPr/>
+        </p:nvSpPr>
+        <p:spPr>
+          <a:xfrm>
+            <a:off x="512064" y="1737360"/>
+            <a:ext cx="3621024" cy="201168"/>
+          </a:xfrm>
+          <a:prstGeom prst="rect">
+            <a:avLst/>
+          </a:prstGeom>
+          <a:noFill/>
+        </p:spPr>
+        <p:txBody>
+          <a:bodyPr wrap="square">
+            <a:noAutofit/>
+          </a:bodyPr>
+          <a:lstStyle/>
+          <a:p>
+            <a:pPr algn="l"/>
+            <a:r>
+              <a:rPr sz="850" b="0" i="0">
+                <a:solidFill>
+                  <a:srgbClr val="7C8D9B"/>
+                </a:solidFill>
+                <a:latin typeface="Poppins"/>
+              </a:rPr>
+              <a:t>Group coaching · Monthly 1:1 coaching call</a:t>
+            </a:r>
+          </a:p>
+        </p:txBody>
+      </p:sp>
+      <p:sp>
+        <p:nvSpPr>
+          <p:cNvPr id="13" name="Rectangle 12"/>
+          <p:cNvSpPr/>
+          <p:nvPr/>
+        </p:nvSpPr>
+        <p:spPr>
+          <a:xfrm>
+            <a:off x="274320" y="2057400"/>
+            <a:ext cx="4041648" cy="960120"/>
+          </a:xfrm>
+          <a:prstGeom prst="rect">
+            <a:avLst/>
+          </a:prstGeom>
+          <a:solidFill>
+            <a:srgbClr val="FFFFFF"/>
+          </a:solidFill>
+          <a:ln>
+            <a:solidFill>
+              <a:srgbClr val="FFFFFF"/>
+            </a:solidFill>
+          </a:ln>
+        </p:spPr>
+        <p:style>
+          <a:lnRef idx="1">
+            <a:schemeClr val="accent1"/>
+          </a:lnRef>
+          <a:fillRef idx="3">
+            <a:schemeClr val="accent1"/>
+          </a:fillRef>
+          <a:effectRef idx="2">
+            <a:schemeClr val="accent1"/>
+          </a:effectRef>
+          <a:fontRef idx="minor">
+            <a:schemeClr val="lt1"/>
+          </a:fontRef>
+        </p:style>
+        <p:txBody>
+          <a:bodyPr rtlCol="0" anchor="ctr"/>
+          <a:lstStyle/>
+          <a:p>
+            <a:pPr algn="ctr"/>
+          </a:p>
+        </p:txBody>
+      </p:sp>
+      <p:sp>
+        <p:nvSpPr>
+          <p:cNvPr id="14" name="Rectangle 13"/>
+          <p:cNvSpPr/>
+          <p:nvPr/>
+        </p:nvSpPr>
+        <p:spPr>
+          <a:xfrm>
+            <a:off x="274320" y="2057400"/>
+            <a:ext cx="36576" cy="960120"/>
+          </a:xfrm>
+          <a:prstGeom prst="rect">
+            <a:avLst/>
+          </a:prstGeom>
+          <a:solidFill>
             <a:srgbClr val="0091C9"/>
           </a:solidFill>
           <a:ln>
@@ -6258,13 +6523,13 @@
       </p:sp>
       <p:sp>
         <p:nvSpPr>
-          <p:cNvPr id="8" name="TextBox 7"/>
+          <p:cNvPr id="15" name="TextBox 14"/>
           <p:cNvSpPr txBox="1"/>
           <p:nvPr/>
         </p:nvSpPr>
         <p:spPr>
           <a:xfrm>
-            <a:off x="512064" y="1115568"/>
+            <a:off x="512064" y="2167128"/>
             <a:ext cx="3621024" cy="182880"/>
           </a:xfrm>
           <a:prstGeom prst="rect">
@@ -6286,20 +6551,20 @@
                 </a:solidFill>
                 <a:latin typeface="Poppins"/>
               </a:rPr>
-              <a:t>FULL SERVICE MARKETING — ESSENTIALS</a:t>
-            </a:r>
-          </a:p>
-        </p:txBody>
-      </p:sp>
-      <p:sp>
-        <p:nvSpPr>
-          <p:cNvPr id="9" name="TextBox 8"/>
+              <a:t>LSA MANAGEMENT ADD-ON</a:t>
+            </a:r>
+          </a:p>
+        </p:txBody>
+      </p:sp>
+      <p:sp>
+        <p:nvSpPr>
+          <p:cNvPr id="16" name="TextBox 15"/>
           <p:cNvSpPr txBox="1"/>
           <p:nvPr/>
         </p:nvSpPr>
         <p:spPr>
           <a:xfrm>
-            <a:off x="512064" y="1252728"/>
+            <a:off x="512064" y="2304288"/>
             <a:ext cx="2377440" cy="530352"/>
           </a:xfrm>
           <a:prstGeom prst="rect">
@@ -6321,20 +6586,20 @@
                 </a:solidFill>
                 <a:latin typeface="Poppins"/>
               </a:rPr>
-              <a:t>$3,797</a:t>
-            </a:r>
-          </a:p>
-        </p:txBody>
-      </p:sp>
-      <p:sp>
-        <p:nvSpPr>
-          <p:cNvPr id="10" name="TextBox 9"/>
+              <a:t>$0</a:t>
+            </a:r>
+          </a:p>
+        </p:txBody>
+      </p:sp>
+      <p:sp>
+        <p:nvSpPr>
+          <p:cNvPr id="17" name="TextBox 16"/>
           <p:cNvSpPr txBox="1"/>
           <p:nvPr/>
         </p:nvSpPr>
         <p:spPr>
           <a:xfrm>
-            <a:off x="1781174" y="1519428"/>
+            <a:off x="1047749" y="2570988"/>
             <a:ext cx="457200" cy="219456"/>
           </a:xfrm>
           <a:prstGeom prst="rect">
@@ -6363,14 +6628,14 @@
       </p:sp>
       <p:sp>
         <p:nvSpPr>
-          <p:cNvPr id="11" name="TextBox 10"/>
+          <p:cNvPr id="18" name="TextBox 17"/>
           <p:cNvSpPr txBox="1"/>
           <p:nvPr/>
         </p:nvSpPr>
         <p:spPr>
           <a:xfrm>
-            <a:off x="2291461" y="1519428"/>
-            <a:ext cx="1933067" cy="219456"/>
+            <a:off x="1558036" y="2570988"/>
+            <a:ext cx="2666492" cy="219456"/>
           </a:xfrm>
           <a:prstGeom prst="rect">
             <a:avLst/>
@@ -6391,20 +6656,20 @@
                 </a:solidFill>
                 <a:latin typeface="Poppins"/>
               </a:rPr>
-              <a:t>stand-alone price</a:t>
-            </a:r>
-          </a:p>
-        </p:txBody>
-      </p:sp>
-      <p:sp>
-        <p:nvSpPr>
-          <p:cNvPr id="12" name="TextBox 11"/>
+              <a:t>$900/mo</a:t>
+            </a:r>
+          </a:p>
+        </p:txBody>
+      </p:sp>
+      <p:sp>
+        <p:nvSpPr>
+          <p:cNvPr id="19" name="TextBox 18"/>
           <p:cNvSpPr txBox="1"/>
           <p:nvPr/>
         </p:nvSpPr>
         <p:spPr>
           <a:xfrm>
-            <a:off x="512064" y="1737360"/>
+            <a:off x="512064" y="2788920"/>
             <a:ext cx="3621024" cy="201168"/>
           </a:xfrm>
           <a:prstGeom prst="rect">
@@ -6426,14 +6691,14 @@
                 </a:solidFill>
                 <a:latin typeface="Poppins"/>
               </a:rPr>
-              <a:t>Website · Local search · GBP · Managed ads</a:t>
-            </a:r>
-          </a:p>
-        </p:txBody>
-      </p:sp>
-      <p:sp>
-        <p:nvSpPr>
-          <p:cNvPr id="13" name="Rectangle 12"/>
+              <a:t>Local Service Ads setup and management · Complimentary</a:t>
+            </a:r>
+          </a:p>
+        </p:txBody>
+      </p:sp>
+      <p:sp>
+        <p:nvSpPr>
+          <p:cNvPr id="20" name="Rectangle 19"/>
           <p:cNvSpPr/>
           <p:nvPr/>
         </p:nvSpPr>
@@ -6478,7 +6743,7 @@
       </p:sp>
       <p:sp>
         <p:nvSpPr>
-          <p:cNvPr id="14" name="Rectangle 13"/>
+          <p:cNvPr id="21" name="Rectangle 20"/>
           <p:cNvSpPr/>
           <p:nvPr/>
         </p:nvSpPr>
@@ -6523,7 +6788,7 @@
       </p:sp>
       <p:sp>
         <p:nvSpPr>
-          <p:cNvPr id="15" name="TextBox 14"/>
+          <p:cNvPr id="22" name="TextBox 21"/>
           <p:cNvSpPr txBox="1"/>
           <p:nvPr/>
         </p:nvSpPr>
@@ -6558,7 +6823,7 @@
       </p:sp>
       <p:sp>
         <p:nvSpPr>
-          <p:cNvPr id="16" name="TextBox 15"/>
+          <p:cNvPr id="23" name="TextBox 22"/>
           <p:cNvSpPr txBox="1"/>
           <p:nvPr/>
         </p:nvSpPr>
@@ -6586,21 +6851,21 @@
                 </a:solidFill>
                 <a:latin typeface="Poppins"/>
               </a:rPr>
-              <a:t>$3,797 / mo</a:t>
-            </a:r>
-          </a:p>
-        </p:txBody>
-      </p:sp>
-      <p:sp>
-        <p:nvSpPr>
-          <p:cNvPr id="17" name="TextBox 16"/>
+              <a:t>$2,497 / mo</a:t>
+            </a:r>
+          </a:p>
+        </p:txBody>
+      </p:sp>
+      <p:sp>
+        <p:nvSpPr>
+          <p:cNvPr id="24" name="TextBox 23"/>
           <p:cNvSpPr txBox="1"/>
           <p:nvPr/>
         </p:nvSpPr>
         <p:spPr>
           <a:xfrm>
-            <a:off x="1948891" y="3460051"/>
-            <a:ext cx="2275636" cy="201168"/>
+            <a:off x="1972208" y="3460051"/>
+            <a:ext cx="2252319" cy="201168"/>
           </a:xfrm>
           <a:prstGeom prst="rect">
             <a:avLst/>
@@ -6615,20 +6880,20 @@
           <a:p>
             <a:pPr algn="r"/>
             <a:r>
-              <a:rPr sz="850" b="0" i="0">
+              <a:rPr sz="800" b="0" i="0">
                 <a:solidFill>
                   <a:srgbClr val="A9D68C"/>
                 </a:solidFill>
                 <a:latin typeface="Poppins"/>
               </a:rPr>
-              <a:t>Stand-alone pricing</a:t>
-            </a:r>
-          </a:p>
-        </p:txBody>
-      </p:sp>
-      <p:sp>
-        <p:nvSpPr>
-          <p:cNvPr id="18" name="Rectangle 17"/>
+              <a:t>Save $900/mo with complimentary LSA</a:t>
+            </a:r>
+          </a:p>
+        </p:txBody>
+      </p:sp>
+      <p:sp>
+        <p:nvSpPr>
+          <p:cNvPr id="25" name="Rectangle 24"/>
           <p:cNvSpPr/>
           <p:nvPr/>
         </p:nvSpPr>
@@ -6673,7 +6938,7 @@
       </p:sp>
       <p:sp>
         <p:nvSpPr>
-          <p:cNvPr id="19" name="TextBox 18"/>
+          <p:cNvPr id="26" name="TextBox 25"/>
           <p:cNvSpPr txBox="1"/>
           <p:nvPr/>
         </p:nvSpPr>
@@ -6701,14 +6966,14 @@
                 </a:solidFill>
                 <a:latin typeface="Poppins"/>
               </a:rPr>
-              <a:t>+ Recommended ad spend: $3,200–$4,950/mo — to reach high-intent Fresno searchers</a:t>
-            </a:r>
-          </a:p>
-        </p:txBody>
-      </p:sp>
-      <p:sp>
-        <p:nvSpPr>
-          <p:cNvPr id="20" name="Rectangle 19"/>
+              <a:t>+ Recommended ad spend: $2,000–$2,500/mo — to reach Fresno searchers ready to call</a:t>
+            </a:r>
+          </a:p>
+        </p:txBody>
+      </p:sp>
+      <p:sp>
+        <p:nvSpPr>
+          <p:cNvPr id="27" name="Rectangle 26"/>
           <p:cNvSpPr/>
           <p:nvPr/>
         </p:nvSpPr>
@@ -6753,7 +7018,7 @@
       </p:sp>
       <p:sp>
         <p:nvSpPr>
-          <p:cNvPr id="21" name="TextBox 20"/>
+          <p:cNvPr id="28" name="TextBox 27"/>
           <p:cNvSpPr txBox="1"/>
           <p:nvPr/>
         </p:nvSpPr>
@@ -6788,7 +7053,7 @@
       </p:sp>
       <p:sp>
         <p:nvSpPr>
-          <p:cNvPr id="22" name="TextBox 21"/>
+          <p:cNvPr id="29" name="TextBox 28"/>
           <p:cNvSpPr txBox="1"/>
           <p:nvPr/>
         </p:nvSpPr>
@@ -6823,7 +7088,7 @@
       </p:sp>
       <p:sp>
         <p:nvSpPr>
-          <p:cNvPr id="23" name="TextBox 22"/>
+          <p:cNvPr id="30" name="TextBox 29"/>
           <p:cNvSpPr txBox="1"/>
           <p:nvPr/>
         </p:nvSpPr>
@@ -6858,7 +7123,7 @@
       </p:sp>
       <p:sp>
         <p:nvSpPr>
-          <p:cNvPr id="24" name="Rectangle 23"/>
+          <p:cNvPr id="31" name="Rectangle 30"/>
           <p:cNvSpPr/>
           <p:nvPr/>
         </p:nvSpPr>
@@ -6903,7 +7168,7 @@
       </p:sp>
       <p:sp>
         <p:nvSpPr>
-          <p:cNvPr id="25" name="TextBox 24"/>
+          <p:cNvPr id="32" name="TextBox 31"/>
           <p:cNvSpPr txBox="1"/>
           <p:nvPr/>
         </p:nvSpPr>
@@ -6931,14 +7196,14 @@
                 </a:solidFill>
                 <a:latin typeface="Poppins"/>
               </a:rPr>
-              <a:t>Conservative  (5–6 cases/mo):</a:t>
-            </a:r>
-          </a:p>
-        </p:txBody>
-      </p:sp>
-      <p:sp>
-        <p:nvSpPr>
-          <p:cNvPr id="26" name="TextBox 25"/>
+              <a:t>Conservative  (2–3 cases/mo):</a:t>
+            </a:r>
+          </a:p>
+        </p:txBody>
+      </p:sp>
+      <p:sp>
+        <p:nvSpPr>
+          <p:cNvPr id="33" name="TextBox 32"/>
           <p:cNvSpPr txBox="1"/>
           <p:nvPr/>
         </p:nvSpPr>
@@ -6966,14 +7231,14 @@
                 </a:solidFill>
                 <a:latin typeface="Poppins"/>
               </a:rPr>
-              <a:t>$21,800 revenue · 6.8× ROAS</a:t>
-            </a:r>
-          </a:p>
-        </p:txBody>
-      </p:sp>
-      <p:sp>
-        <p:nvSpPr>
-          <p:cNvPr id="27" name="TextBox 26"/>
+              <a:t>$10,400 revenue · 5.2× ROAS</a:t>
+            </a:r>
+          </a:p>
+        </p:txBody>
+      </p:sp>
+      <p:sp>
+        <p:nvSpPr>
+          <p:cNvPr id="34" name="TextBox 33"/>
           <p:cNvSpPr txBox="1"/>
           <p:nvPr/>
         </p:nvSpPr>
@@ -7001,14 +7266,14 @@
                 </a:solidFill>
                 <a:latin typeface="Poppins"/>
               </a:rPr>
-              <a:t>Aggressive  (9–10 cases/mo):</a:t>
-            </a:r>
-          </a:p>
-        </p:txBody>
-      </p:sp>
-      <p:sp>
-        <p:nvSpPr>
-          <p:cNvPr id="28" name="TextBox 27"/>
+              <a:t>Aggressive  (3–4 cases/mo):</a:t>
+            </a:r>
+          </a:p>
+        </p:txBody>
+      </p:sp>
+      <p:sp>
+        <p:nvSpPr>
+          <p:cNvPr id="35" name="TextBox 34"/>
           <p:cNvSpPr txBox="1"/>
           <p:nvPr/>
         </p:nvSpPr>
@@ -7036,14 +7301,14 @@
                 </a:solidFill>
                 <a:latin typeface="Poppins"/>
               </a:rPr>
-              <a:t>$36,500 revenue · 7.4× ROAS</a:t>
-            </a:r>
-          </a:p>
-        </p:txBody>
-      </p:sp>
-      <p:sp>
-        <p:nvSpPr>
-          <p:cNvPr id="29" name="TextBox 28"/>
+              <a:t>$15,600 revenue · 6.2× ROAS</a:t>
+            </a:r>
+          </a:p>
+        </p:txBody>
+      </p:sp>
+      <p:sp>
+        <p:nvSpPr>
+          <p:cNvPr id="36" name="TextBox 35"/>
           <p:cNvSpPr txBox="1"/>
           <p:nvPr/>
         </p:nvSpPr>
@@ -7078,7 +7343,7 @@
       </p:sp>
       <p:sp>
         <p:nvSpPr>
-          <p:cNvPr id="30" name="Rectangle 29"/>
+          <p:cNvPr id="37" name="Rectangle 36"/>
           <p:cNvSpPr/>
           <p:nvPr/>
         </p:nvSpPr>
@@ -7123,7 +7388,7 @@
       </p:sp>
       <p:sp>
         <p:nvSpPr>
-          <p:cNvPr id="31" name="Rectangle 30"/>
+          <p:cNvPr id="38" name="Rectangle 37"/>
           <p:cNvSpPr/>
           <p:nvPr/>
         </p:nvSpPr>
@@ -7168,7 +7433,7 @@
       </p:sp>
       <p:sp>
         <p:nvSpPr>
-          <p:cNvPr id="32" name="TextBox 31"/>
+          <p:cNvPr id="39" name="TextBox 38"/>
           <p:cNvSpPr txBox="1"/>
           <p:nvPr/>
         </p:nvSpPr>
@@ -7203,7 +7468,7 @@
       </p:sp>
       <p:sp>
         <p:nvSpPr>
-          <p:cNvPr id="33" name="TextBox 32"/>
+          <p:cNvPr id="40" name="TextBox 39"/>
           <p:cNvSpPr txBox="1"/>
           <p:nvPr/>
         </p:nvSpPr>
@@ -7231,14 +7496,14 @@
                 </a:solidFill>
                 <a:latin typeface="Poppins"/>
               </a:rPr>
-              <a:t>Managed ads and local search add a second source</a:t>
-            </a:r>
-          </a:p>
-        </p:txBody>
-      </p:sp>
-      <p:sp>
-        <p:nvSpPr>
-          <p:cNvPr id="34" name="Rectangle 33"/>
+              <a:t>LSA adds a second source; pay when a prospect calls</a:t>
+            </a:r>
+          </a:p>
+        </p:txBody>
+      </p:sp>
+      <p:sp>
+        <p:nvSpPr>
+          <p:cNvPr id="41" name="Rectangle 40"/>
           <p:cNvSpPr/>
           <p:nvPr/>
         </p:nvSpPr>
@@ -7283,7 +7548,7 @@
       </p:sp>
       <p:sp>
         <p:nvSpPr>
-          <p:cNvPr id="35" name="Rectangle 34"/>
+          <p:cNvPr id="42" name="Rectangle 41"/>
           <p:cNvSpPr/>
           <p:nvPr/>
         </p:nvSpPr>
@@ -7328,7 +7593,7 @@
       </p:sp>
       <p:sp>
         <p:nvSpPr>
-          <p:cNvPr id="36" name="TextBox 35"/>
+          <p:cNvPr id="43" name="TextBox 42"/>
           <p:cNvSpPr txBox="1"/>
           <p:nvPr/>
         </p:nvSpPr>
@@ -7356,14 +7621,14 @@
                 </a:solidFill>
                 <a:latin typeface="Poppins"/>
               </a:rPr>
-              <a:t>Branding</a:t>
-            </a:r>
-          </a:p>
-        </p:txBody>
-      </p:sp>
-      <p:sp>
-        <p:nvSpPr>
-          <p:cNvPr id="37" name="TextBox 36"/>
+              <a:t>Needs framework</a:t>
+            </a:r>
+          </a:p>
+        </p:txBody>
+      </p:sp>
+      <p:sp>
+        <p:nvSpPr>
+          <p:cNvPr id="44" name="TextBox 43"/>
           <p:cNvSpPr txBox="1"/>
           <p:nvPr/>
         </p:nvSpPr>
@@ -7385,20 +7650,20 @@
           <a:p>
             <a:pPr algn="l"/>
             <a:r>
-              <a:rPr sz="750" b="0" i="0">
+              <a:rPr sz="800" b="0" i="0">
                 <a:solidFill>
                   <a:srgbClr val="4A5C6B"/>
                 </a:solidFill>
                 <a:latin typeface="Poppins"/>
               </a:rPr>
-              <a:t>Site content written around your credentials and story</a:t>
-            </a:r>
-          </a:p>
-        </p:txBody>
-      </p:sp>
-      <p:sp>
-        <p:nvSpPr>
-          <p:cNvPr id="38" name="Rectangle 37"/>
+              <a:t>Monthly 1:1 coaching to map options and first hires</a:t>
+            </a:r>
+          </a:p>
+        </p:txBody>
+      </p:sp>
+      <p:sp>
+        <p:nvSpPr>
+          <p:cNvPr id="45" name="Rectangle 44"/>
           <p:cNvSpPr/>
           <p:nvPr/>
         </p:nvSpPr>
@@ -7443,7 +7708,7 @@
       </p:sp>
       <p:sp>
         <p:nvSpPr>
-          <p:cNvPr id="39" name="Rectangle 38"/>
+          <p:cNvPr id="46" name="Rectangle 45"/>
           <p:cNvSpPr/>
           <p:nvPr/>
         </p:nvSpPr>
@@ -7488,7 +7753,7 @@
       </p:sp>
       <p:sp>
         <p:nvSpPr>
-          <p:cNvPr id="40" name="TextBox 39"/>
+          <p:cNvPr id="47" name="TextBox 46"/>
           <p:cNvSpPr txBox="1"/>
           <p:nvPr/>
         </p:nvSpPr>
@@ -7516,14 +7781,14 @@
                 </a:solidFill>
                 <a:latin typeface="Poppins"/>
               </a:rPr>
-              <a:t>Scaling the firm</a:t>
-            </a:r>
-          </a:p>
-        </p:txBody>
-      </p:sp>
-      <p:sp>
-        <p:nvSpPr>
-          <p:cNvPr id="41" name="TextBox 40"/>
+              <a:t>Solo, lean start</a:t>
+            </a:r>
+          </a:p>
+        </p:txBody>
+      </p:sp>
+      <p:sp>
+        <p:nvSpPr>
+          <p:cNvPr id="48" name="TextBox 47"/>
           <p:cNvSpPr txBox="1"/>
           <p:nvPr/>
         </p:nvSpPr>
@@ -7551,14 +7816,14 @@
                 </a:solidFill>
                 <a:latin typeface="Poppins"/>
               </a:rPr>
-              <a:t>Case volume that can fund the associates you want</a:t>
-            </a:r>
-          </a:p>
-        </p:txBody>
-      </p:sp>
-      <p:sp>
-        <p:nvSpPr>
-          <p:cNvPr id="42" name="Rectangle 41"/>
+              <a:t>One coaching plan; LSA management fee included</a:t>
+            </a:r>
+          </a:p>
+        </p:txBody>
+      </p:sp>
+      <p:sp>
+        <p:nvSpPr>
+          <p:cNvPr id="49" name="Rectangle 48"/>
           <p:cNvSpPr/>
           <p:nvPr/>
         </p:nvSpPr>
@@ -7603,7 +7868,7 @@
       </p:sp>
       <p:sp>
         <p:nvSpPr>
-          <p:cNvPr id="43" name="Rectangle 42"/>
+          <p:cNvPr id="50" name="Rectangle 49"/>
           <p:cNvSpPr/>
           <p:nvPr/>
         </p:nvSpPr>
@@ -7648,7 +7913,7 @@
       </p:sp>
       <p:sp>
         <p:nvSpPr>
-          <p:cNvPr id="44" name="TextBox 43"/>
+          <p:cNvPr id="51" name="TextBox 50"/>
           <p:cNvSpPr txBox="1"/>
           <p:nvPr/>
         </p:nvSpPr>
@@ -7683,7 +7948,7 @@
       </p:sp>
       <p:sp>
         <p:nvSpPr>
-          <p:cNvPr id="45" name="Rectangle 44"/>
+          <p:cNvPr id="52" name="Rectangle 51"/>
           <p:cNvSpPr/>
           <p:nvPr/>
         </p:nvSpPr>
@@ -7728,7 +7993,7 @@
       </p:sp>
       <p:pic>
         <p:nvPicPr>
-          <p:cNvPr id="46" name="Picture 45" descr="smb_team_logo.png"/>
+          <p:cNvPr id="53" name="Picture 52" descr="smb_team_logo.png"/>
           <p:cNvPicPr>
             <a:picLocks noChangeAspect="1"/>
           </p:cNvPicPr>
@@ -7752,7 +8017,7 @@
       </p:pic>
       <p:sp>
         <p:nvSpPr>
-          <p:cNvPr id="47" name="TextBox 46"/>
+          <p:cNvPr id="54" name="TextBox 53"/>
           <p:cNvSpPr txBox="1"/>
           <p:nvPr/>
         </p:nvSpPr>
@@ -7787,7 +8052,7 @@
       </p:sp>
       <p:sp>
         <p:nvSpPr>
-          <p:cNvPr id="48" name="TextBox 47"/>
+          <p:cNvPr id="55" name="TextBox 54"/>
           <p:cNvSpPr txBox="1"/>
           <p:nvPr/>
         </p:nvSpPr>

</xml_diff>